<commit_message>
Control adaptativo (Q-learning) en los 3 cruces, semaforos en su posicion real, diagramas espacio-tiempo de onda verde y reporte/presentacion actualizados
</commit_message>
<xml_diff>
--- a/documentacion/Presentacion_Final_OndaVerde.pptx
+++ b/documentacion/Presentacion_Final_OndaVerde.pptx
@@ -659,7 +659,7 @@
           <a:lstStyle/>
           <a:p>
             <a:r>
-              <a:t>Esta es la gráfica corregida: ahora son trayectorias REALES de la simulación, no una línea idealizada. Sin coordinación se ve cómo los vehículos se detienen en cada cruce.</a:t>
+              <a:t>Bandas verde/rojo reales de cada semáforo y el pelotón como rectas a velocidad de sincronía. Sin coordinación los verdes están alineados y el pelotón choca con los rojos de C2 y C1.</a:t>
             </a:r>
           </a:p>
         </p:txBody>
@@ -729,7 +729,7 @@
           <a:lstStyle/>
           <a:p>
             <a:r>
-              <a:t>Con onda verde las bandas verdes se escalonan formando el canal diagonal, y el pelotón lo recorre sin parar. La diferencia con la anterior es la onda verde, vista de verdad en la simulación.</a:t>
+              <a:t>Mismas rectas, pero ahora los verdes se escalonan formando el canal diagonal de la onda verde, y el pelotón lo recorre sin parar. Esa es la diferencia que aporta la coordinación.</a:t>
             </a:r>
           </a:p>
         </p:txBody>
@@ -939,7 +939,7 @@
           <a:lstStyle/>
           <a:p>
             <a:r>
-              <a:t>En Unity se conmutan los 3 escenarios en vivo. Se ve el cambio de fase, las vueltas en U y el tráfico. Verificamos sin interfaz que ningún vehículo cruza en rojo.</a:t>
+              <a:t>En Unity los 3 cruces corren el control adaptativo Q-learning: cada semáforo sensa sus colas y decide el verde en vivo. La comparación de los 3 escenarios vive en Python. Verificamos sin interfaz que ningún vehículo cruza en rojo.</a:t>
             </a:r>
           </a:p>
         </p:txBody>
@@ -5100,7 +5100,7 @@
                 </a:solidFill>
                 <a:latin typeface="Calibri"/>
               </a:rPr>
-              <a:t>Trayectorias reales de la simulación: los vehículos chocan con los rojos y se detienen (puntos rojos).</a:t>
+              <a:t>Los verdes abren al mismo tiempo: el pelotón (líneas rectas a velocidad de sincronía) llega en rojo a los cruces de aguas abajo.</a:t>
             </a:r>
           </a:p>
         </p:txBody>
@@ -5220,7 +5220,7 @@
                 </a:solidFill>
                 <a:latin typeface="Calibri"/>
               </a:rPr>
-              <a:t>Las bandas verdes se escalonan y el pelotón se desliza por el canal verde sin detenerse.</a:t>
+              <a:t>Los verdes se escalonan según el offset d/v: el pelotón viaja sobre la banda verde sin detenerse.</a:t>
             </a:r>
           </a:p>
         </p:txBody>
@@ -5521,14 +5521,14 @@
                 </a:solidFill>
                 <a:latin typeface="Calibri"/>
               </a:rPr>
-              <a:t>Simulación visual (Unity): 3 escenarios conmutables</a:t>
+              <a:t>Simulación visual (Unity): control adaptativo en lazo cerrado</a:t>
             </a:r>
           </a:p>
         </p:txBody>
       </p:sp>
       <p:pic>
         <p:nvPicPr>
-          <p:cNvPr id="3" name="Picture 2" descr="escenario_ondaverde.png"/>
+          <p:cNvPr id="3" name="Picture 2" descr="escenario_adaptativo.png"/>
           <p:cNvPicPr>
             <a:picLocks noChangeAspect="1"/>
           </p:cNvPicPr>
@@ -5580,7 +5580,7 @@
                 </a:solidFill>
                 <a:latin typeface="Calibri"/>
               </a:rPr>
-              <a:t>Teclas 1/2/3 cambian de estrategia en vivo. Auditoría: 0 vehículos cruzando en rojo en los 3 escenarios.</a:t>
+              <a:t>Los 3 cruces corren el control adaptativo (Q-learning) sensando sus colas. Auditoría: 0 vehículos cruzando en rojo.</a:t>
             </a:r>
           </a:p>
         </p:txBody>

</xml_diff>